<commit_message>
Rename to MNOffice, part of Mundus Novus
New icons and palette, office.mundusnovus.org, the MNOffice desktop app,
and the writing font renamed Novus Serif (rebuilt from Liberation Serif,
OFL) with the blank templates updated to use it.

Co-Authored-By: Claude Opus 5.5 <noreply@anthropic.com>
</commit_message>
<xml_diff>
--- a/portal/templates/blank.pptx
+++ b/portal/templates/blank.pptx
@@ -518,8 +518,8 @@
           <a:lstStyle/>
           <a:p>
             <a:endParaRPr lang="en-US" dirty="0">
-              <a:latin typeface="Christian Sans" panose="020B0604020202020204" pitchFamily="34" charset="0"/>
-              <a:cs typeface="Christian Sans" panose="020B0604020202020204" pitchFamily="34" charset="0"/>
+              <a:latin typeface="Novus Serif" panose="020B0604020202020204" pitchFamily="34" charset="0"/>
+              <a:cs typeface="Novus Serif" panose="020B0604020202020204" pitchFamily="34" charset="0"/>
             </a:endParaRPr>
           </a:p>
         </p:txBody>
@@ -3149,7 +3149,7 @@
         <a:spcBef>
           <a:spcPts val="1000"/>
         </a:spcBef>
-        <a:buFont typeface="Christian Sans" panose="020B0604020202020204" pitchFamily="34" charset="0"/>
+        <a:buFont typeface="Novus Serif" panose="020B0604020202020204" pitchFamily="34" charset="0"/>
         <a:buChar char="•"/>
         <a:defRPr sz="2800" kern="1200">
           <a:solidFill>
@@ -3167,7 +3167,7 @@
         <a:spcBef>
           <a:spcPts val="500"/>
         </a:spcBef>
-        <a:buFont typeface="Christian Sans" panose="020B0604020202020204" pitchFamily="34" charset="0"/>
+        <a:buFont typeface="Novus Serif" panose="020B0604020202020204" pitchFamily="34" charset="0"/>
         <a:buChar char="•"/>
         <a:defRPr sz="2400" kern="1200">
           <a:solidFill>
@@ -3185,7 +3185,7 @@
         <a:spcBef>
           <a:spcPts val="500"/>
         </a:spcBef>
-        <a:buFont typeface="Christian Sans" panose="020B0604020202020204" pitchFamily="34" charset="0"/>
+        <a:buFont typeface="Novus Serif" panose="020B0604020202020204" pitchFamily="34" charset="0"/>
         <a:buChar char="•"/>
         <a:defRPr sz="2000" kern="1200">
           <a:solidFill>
@@ -3203,7 +3203,7 @@
         <a:spcBef>
           <a:spcPts val="500"/>
         </a:spcBef>
-        <a:buFont typeface="Christian Sans" panose="020B0604020202020204" pitchFamily="34" charset="0"/>
+        <a:buFont typeface="Novus Serif" panose="020B0604020202020204" pitchFamily="34" charset="0"/>
         <a:buChar char="•"/>
         <a:defRPr sz="1800" kern="1200">
           <a:solidFill>
@@ -3221,7 +3221,7 @@
         <a:spcBef>
           <a:spcPts val="500"/>
         </a:spcBef>
-        <a:buFont typeface="Christian Sans" panose="020B0604020202020204" pitchFamily="34" charset="0"/>
+        <a:buFont typeface="Novus Serif" panose="020B0604020202020204" pitchFamily="34" charset="0"/>
         <a:buChar char="•"/>
         <a:defRPr sz="1800" kern="1200">
           <a:solidFill>
@@ -3239,7 +3239,7 @@
         <a:spcBef>
           <a:spcPts val="500"/>
         </a:spcBef>
-        <a:buFont typeface="Christian Sans" panose="020B0604020202020204" pitchFamily="34" charset="0"/>
+        <a:buFont typeface="Novus Serif" panose="020B0604020202020204" pitchFamily="34" charset="0"/>
         <a:buChar char="•"/>
         <a:defRPr sz="1800" kern="1200">
           <a:solidFill>
@@ -3257,7 +3257,7 @@
         <a:spcBef>
           <a:spcPts val="500"/>
         </a:spcBef>
-        <a:buFont typeface="Christian Sans" panose="020B0604020202020204" pitchFamily="34" charset="0"/>
+        <a:buFont typeface="Novus Serif" panose="020B0604020202020204" pitchFamily="34" charset="0"/>
         <a:buChar char="•"/>
         <a:defRPr sz="1800" kern="1200">
           <a:solidFill>
@@ -3275,7 +3275,7 @@
         <a:spcBef>
           <a:spcPts val="500"/>
         </a:spcBef>
-        <a:buFont typeface="Christian Sans" panose="020B0604020202020204" pitchFamily="34" charset="0"/>
+        <a:buFont typeface="Novus Serif" panose="020B0604020202020204" pitchFamily="34" charset="0"/>
         <a:buChar char="•"/>
         <a:defRPr sz="1800" kern="1200">
           <a:solidFill>
@@ -3293,7 +3293,7 @@
         <a:spcBef>
           <a:spcPts val="500"/>
         </a:spcBef>
-        <a:buFont typeface="Christian Sans" panose="020B0604020202020204" pitchFamily="34" charset="0"/>
+        <a:buFont typeface="Novus Serif" panose="020B0604020202020204" pitchFamily="34" charset="0"/>
         <a:buChar char="•"/>
         <a:defRPr sz="1800" kern="1200">
           <a:solidFill>
@@ -3515,15 +3515,15 @@
     </a:clrScheme>
     <a:fontScheme name="Office Theme">
       <a:majorFont>
-        <a:latin typeface="Christian Sans" panose="020F0302020204030204"/>
+        <a:latin typeface="Novus Serif" panose="020F0302020204030204"/>
         <a:ea typeface=""/>
         <a:cs typeface=""/>
         <a:font script="Jpan" typeface="ＭＳ Ｐゴシック"/>
         <a:font script="Hang" typeface="맑은 고딕"/>
         <a:font script="Hans" typeface="宋体"/>
         <a:font script="Hant" typeface="新細明體"/>
-        <a:font script="Arab" typeface="Christian Sans"/>
-        <a:font script="Hebr" typeface="Christian Sans"/>
+        <a:font script="Arab" typeface="Novus Serif"/>
+        <a:font script="Hebr" typeface="Novus Serif"/>
         <a:font script="Thai" typeface="Angsana New"/>
         <a:font script="Ethi" typeface="Nyala"/>
         <a:font script="Beng" typeface="Vrinda"/>
@@ -3545,20 +3545,20 @@
         <a:font script="Laoo" typeface="DokChampa"/>
         <a:font script="Sinh" typeface="Iskoola Pota"/>
         <a:font script="Mong" typeface="Mongolian Baiti"/>
-        <a:font script="Viet" typeface="Christian Sans"/>
+        <a:font script="Viet" typeface="Novus Serif"/>
         <a:font script="Uigh" typeface="Microsoft Uighur"/>
         <a:font script="Geor" typeface="Sylfaen"/>
       </a:majorFont>
       <a:minorFont>
-        <a:latin typeface="Christian Sans" panose="020F0502020204030204"/>
+        <a:latin typeface="Novus Serif" panose="020F0502020204030204"/>
         <a:ea typeface=""/>
         <a:cs typeface=""/>
         <a:font script="Jpan" typeface="ＭＳ Ｐゴシック"/>
         <a:font script="Hang" typeface="맑은 고딕"/>
         <a:font script="Hans" typeface="宋体"/>
         <a:font script="Hant" typeface="新細明體"/>
-        <a:font script="Arab" typeface="Christian Sans"/>
-        <a:font script="Hebr" typeface="Christian Sans"/>
+        <a:font script="Arab" typeface="Novus Serif"/>
+        <a:font script="Hebr" typeface="Novus Serif"/>
         <a:font script="Thai" typeface="Cordia New"/>
         <a:font script="Ethi" typeface="Nyala"/>
         <a:font script="Beng" typeface="Vrinda"/>
@@ -3580,7 +3580,7 @@
         <a:font script="Laoo" typeface="DokChampa"/>
         <a:font script="Sinh" typeface="Iskoola Pota"/>
         <a:font script="Mong" typeface="Mongolian Baiti"/>
-        <a:font script="Viet" typeface="Christian Sans"/>
+        <a:font script="Viet" typeface="Novus Serif"/>
         <a:font script="Uigh" typeface="Microsoft Uighur"/>
         <a:font script="Geor" typeface="Sylfaen"/>
       </a:minorFont>
@@ -3774,9 +3774,9 @@
         <a:srgbClr val="954F72"/>
       </a:folHlink>
     </a:clrScheme>
-    <a:fontScheme name="Christian Sans">
+    <a:fontScheme name="Novus Serif">
       <a:majorFont>
-        <a:latin typeface="Christian Sans" panose="020B0604020202020204"/>
+        <a:latin typeface="Novus Serif" panose="020B0604020202020204"/>
         <a:ea typeface=""/>
         <a:cs typeface=""/>
         <a:font script="Jpan" typeface="ＭＳ ゴシック"/>
@@ -3811,7 +3811,7 @@
         <a:font script="Geor" typeface="Sylfaen"/>
       </a:majorFont>
       <a:minorFont>
-        <a:latin typeface="Christian Sans" panose="020B0604020202020204"/>
+        <a:latin typeface="Novus Serif" panose="020B0604020202020204"/>
         <a:ea typeface=""/>
         <a:cs typeface=""/>
         <a:font script="Jpan" typeface="ＭＳ ゴシック"/>

</xml_diff>

<commit_message>
Rename to Asteria Office, part of Asteria Technology
New name, asteria.technology addresses, the teal palette and the new icons,
fonts renamed Asteria Pixel and Asteria Serif, and the Asteria License.
Settings and files saved under the earlier names still load.

Co-Authored-By: Claude Opus 5.5 <noreply@anthropic.com>
</commit_message>
<xml_diff>
--- a/portal/templates/blank.pptx
+++ b/portal/templates/blank.pptx
@@ -518,8 +518,8 @@
           <a:lstStyle/>
           <a:p>
             <a:endParaRPr lang="en-US" dirty="0">
-              <a:latin typeface="Novus Serif" panose="020B0604020202020204" pitchFamily="34" charset="0"/>
-              <a:cs typeface="Novus Serif" panose="020B0604020202020204" pitchFamily="34" charset="0"/>
+              <a:latin typeface="Asteria Serif" panose="020B0604020202020204" pitchFamily="34" charset="0"/>
+              <a:cs typeface="Asteria Serif" panose="020B0604020202020204" pitchFamily="34" charset="0"/>
             </a:endParaRPr>
           </a:p>
         </p:txBody>
@@ -3149,7 +3149,7 @@
         <a:spcBef>
           <a:spcPts val="1000"/>
         </a:spcBef>
-        <a:buFont typeface="Novus Serif" panose="020B0604020202020204" pitchFamily="34" charset="0"/>
+        <a:buFont typeface="Asteria Serif" panose="020B0604020202020204" pitchFamily="34" charset="0"/>
         <a:buChar char="•"/>
         <a:defRPr sz="2800" kern="1200">
           <a:solidFill>
@@ -3167,7 +3167,7 @@
         <a:spcBef>
           <a:spcPts val="500"/>
         </a:spcBef>
-        <a:buFont typeface="Novus Serif" panose="020B0604020202020204" pitchFamily="34" charset="0"/>
+        <a:buFont typeface="Asteria Serif" panose="020B0604020202020204" pitchFamily="34" charset="0"/>
         <a:buChar char="•"/>
         <a:defRPr sz="2400" kern="1200">
           <a:solidFill>
@@ -3185,7 +3185,7 @@
         <a:spcBef>
           <a:spcPts val="500"/>
         </a:spcBef>
-        <a:buFont typeface="Novus Serif" panose="020B0604020202020204" pitchFamily="34" charset="0"/>
+        <a:buFont typeface="Asteria Serif" panose="020B0604020202020204" pitchFamily="34" charset="0"/>
         <a:buChar char="•"/>
         <a:defRPr sz="2000" kern="1200">
           <a:solidFill>
@@ -3203,7 +3203,7 @@
         <a:spcBef>
           <a:spcPts val="500"/>
         </a:spcBef>
-        <a:buFont typeface="Novus Serif" panose="020B0604020202020204" pitchFamily="34" charset="0"/>
+        <a:buFont typeface="Asteria Serif" panose="020B0604020202020204" pitchFamily="34" charset="0"/>
         <a:buChar char="•"/>
         <a:defRPr sz="1800" kern="1200">
           <a:solidFill>
@@ -3221,7 +3221,7 @@
         <a:spcBef>
           <a:spcPts val="500"/>
         </a:spcBef>
-        <a:buFont typeface="Novus Serif" panose="020B0604020202020204" pitchFamily="34" charset="0"/>
+        <a:buFont typeface="Asteria Serif" panose="020B0604020202020204" pitchFamily="34" charset="0"/>
         <a:buChar char="•"/>
         <a:defRPr sz="1800" kern="1200">
           <a:solidFill>
@@ -3239,7 +3239,7 @@
         <a:spcBef>
           <a:spcPts val="500"/>
         </a:spcBef>
-        <a:buFont typeface="Novus Serif" panose="020B0604020202020204" pitchFamily="34" charset="0"/>
+        <a:buFont typeface="Asteria Serif" panose="020B0604020202020204" pitchFamily="34" charset="0"/>
         <a:buChar char="•"/>
         <a:defRPr sz="1800" kern="1200">
           <a:solidFill>
@@ -3257,7 +3257,7 @@
         <a:spcBef>
           <a:spcPts val="500"/>
         </a:spcBef>
-        <a:buFont typeface="Novus Serif" panose="020B0604020202020204" pitchFamily="34" charset="0"/>
+        <a:buFont typeface="Asteria Serif" panose="020B0604020202020204" pitchFamily="34" charset="0"/>
         <a:buChar char="•"/>
         <a:defRPr sz="1800" kern="1200">
           <a:solidFill>
@@ -3275,7 +3275,7 @@
         <a:spcBef>
           <a:spcPts val="500"/>
         </a:spcBef>
-        <a:buFont typeface="Novus Serif" panose="020B0604020202020204" pitchFamily="34" charset="0"/>
+        <a:buFont typeface="Asteria Serif" panose="020B0604020202020204" pitchFamily="34" charset="0"/>
         <a:buChar char="•"/>
         <a:defRPr sz="1800" kern="1200">
           <a:solidFill>
@@ -3293,7 +3293,7 @@
         <a:spcBef>
           <a:spcPts val="500"/>
         </a:spcBef>
-        <a:buFont typeface="Novus Serif" panose="020B0604020202020204" pitchFamily="34" charset="0"/>
+        <a:buFont typeface="Asteria Serif" panose="020B0604020202020204" pitchFamily="34" charset="0"/>
         <a:buChar char="•"/>
         <a:defRPr sz="1800" kern="1200">
           <a:solidFill>
@@ -3515,15 +3515,15 @@
     </a:clrScheme>
     <a:fontScheme name="Office Theme">
       <a:majorFont>
-        <a:latin typeface="Novus Serif" panose="020F0302020204030204"/>
+        <a:latin typeface="Asteria Serif" panose="020F0302020204030204"/>
         <a:ea typeface=""/>
         <a:cs typeface=""/>
         <a:font script="Jpan" typeface="ＭＳ Ｐゴシック"/>
         <a:font script="Hang" typeface="맑은 고딕"/>
         <a:font script="Hans" typeface="宋体"/>
         <a:font script="Hant" typeface="新細明體"/>
-        <a:font script="Arab" typeface="Novus Serif"/>
-        <a:font script="Hebr" typeface="Novus Serif"/>
+        <a:font script="Arab" typeface="Asteria Serif"/>
+        <a:font script="Hebr" typeface="Asteria Serif"/>
         <a:font script="Thai" typeface="Angsana New"/>
         <a:font script="Ethi" typeface="Nyala"/>
         <a:font script="Beng" typeface="Vrinda"/>
@@ -3545,20 +3545,20 @@
         <a:font script="Laoo" typeface="DokChampa"/>
         <a:font script="Sinh" typeface="Iskoola Pota"/>
         <a:font script="Mong" typeface="Mongolian Baiti"/>
-        <a:font script="Viet" typeface="Novus Serif"/>
+        <a:font script="Viet" typeface="Asteria Serif"/>
         <a:font script="Uigh" typeface="Microsoft Uighur"/>
         <a:font script="Geor" typeface="Sylfaen"/>
       </a:majorFont>
       <a:minorFont>
-        <a:latin typeface="Novus Serif" panose="020F0502020204030204"/>
+        <a:latin typeface="Asteria Serif" panose="020F0502020204030204"/>
         <a:ea typeface=""/>
         <a:cs typeface=""/>
         <a:font script="Jpan" typeface="ＭＳ Ｐゴシック"/>
         <a:font script="Hang" typeface="맑은 고딕"/>
         <a:font script="Hans" typeface="宋体"/>
         <a:font script="Hant" typeface="新細明體"/>
-        <a:font script="Arab" typeface="Novus Serif"/>
-        <a:font script="Hebr" typeface="Novus Serif"/>
+        <a:font script="Arab" typeface="Asteria Serif"/>
+        <a:font script="Hebr" typeface="Asteria Serif"/>
         <a:font script="Thai" typeface="Cordia New"/>
         <a:font script="Ethi" typeface="Nyala"/>
         <a:font script="Beng" typeface="Vrinda"/>
@@ -3580,7 +3580,7 @@
         <a:font script="Laoo" typeface="DokChampa"/>
         <a:font script="Sinh" typeface="Iskoola Pota"/>
         <a:font script="Mong" typeface="Mongolian Baiti"/>
-        <a:font script="Viet" typeface="Novus Serif"/>
+        <a:font script="Viet" typeface="Asteria Serif"/>
         <a:font script="Uigh" typeface="Microsoft Uighur"/>
         <a:font script="Geor" typeface="Sylfaen"/>
       </a:minorFont>
@@ -3774,9 +3774,9 @@
         <a:srgbClr val="954F72"/>
       </a:folHlink>
     </a:clrScheme>
-    <a:fontScheme name="Novus Serif">
+    <a:fontScheme name="Asteria Serif">
       <a:majorFont>
-        <a:latin typeface="Novus Serif" panose="020B0604020202020204"/>
+        <a:latin typeface="Asteria Serif" panose="020B0604020202020204"/>
         <a:ea typeface=""/>
         <a:cs typeface=""/>
         <a:font script="Jpan" typeface="ＭＳ ゴシック"/>
@@ -3811,7 +3811,7 @@
         <a:font script="Geor" typeface="Sylfaen"/>
       </a:majorFont>
       <a:minorFont>
-        <a:latin typeface="Novus Serif" panose="020B0604020202020204"/>
+        <a:latin typeface="Asteria Serif" panose="020B0604020202020204"/>
         <a:ea typeface=""/>
         <a:cs typeface=""/>
         <a:font script="Jpan" typeface="ＭＳ ゴシック"/>

</xml_diff>